<commit_message>
Update dashboard validation and project documentation
Co-authored-by: Copilot <223556219+Copilot@users.noreply.github.com>
</commit_message>
<xml_diff>
--- a/docs/presentation/Final_Project_Presentation.pptx
+++ b/docs/presentation/Final_Project_Presentation.pptx
@@ -12041,7 +12041,7 @@
                 <a:ea typeface="Aptos"/>
                 <a:cs typeface="Aptos"/>
               </a:rPr>
-              <a:t>Implemented request flow (conceptual)</a:t>
+              <a:t>Request validation, identity checks, storage, and monitoring</a:t>
             </a:r>
           </a:p>
         </p:txBody>
@@ -13750,7 +13750,7 @@
                 <a:ea typeface="Aptos"/>
                 <a:cs typeface="Aptos"/>
               </a:rPr>
-              <a:t>Process request</a:t>
+              <a:t>Validate + process</a:t>
             </a:r>
           </a:p>
         </p:txBody>
@@ -14184,6 +14184,10 @@
             <a:schemeClr val="tx1"/>
           </a:fontRef>
         </p:style>
+        <p:txBody xmlns:a="http://schemas.openxmlformats.org/drawingml/2006/main">
+          <a:bodyPr/>
+          <a:p/>
+        </p:txBody>
       </p:sp>
       <p:sp>
         <p:nvSpPr>
@@ -14228,6 +14232,10 @@
             <a:schemeClr val="tx1"/>
           </a:fontRef>
         </p:style>
+        <p:txBody xmlns:a="http://schemas.openxmlformats.org/drawingml/2006/main">
+          <a:bodyPr/>
+          <a:p/>
+        </p:txBody>
       </p:sp>
       <p:sp>
         <p:nvSpPr>
@@ -14272,6 +14280,10 @@
             <a:schemeClr val="tx1"/>
           </a:fontRef>
         </p:style>
+        <p:txBody xmlns:a="http://schemas.openxmlformats.org/drawingml/2006/main">
+          <a:bodyPr/>
+          <a:p/>
+        </p:txBody>
       </p:sp>
       <p:sp>
         <p:nvSpPr>
@@ -14316,6 +14328,10 @@
             <a:schemeClr val="tx1"/>
           </a:fontRef>
         </p:style>
+        <p:txBody xmlns:a="http://schemas.openxmlformats.org/drawingml/2006/main">
+          <a:bodyPr/>
+          <a:p/>
+        </p:txBody>
       </p:sp>
       <p:sp>
         <p:nvSpPr>
@@ -15680,6 +15696,10 @@
             <a:schemeClr val="tx1"/>
           </a:fontRef>
         </p:style>
+        <p:txBody xmlns:a="http://schemas.openxmlformats.org/drawingml/2006/main">
+          <a:bodyPr/>
+          <a:p/>
+        </p:txBody>
       </p:sp>
       <p:sp>
         <p:nvSpPr>
@@ -15724,6 +15744,10 @@
             <a:schemeClr val="tx1"/>
           </a:fontRef>
         </p:style>
+        <p:txBody xmlns:a="http://schemas.openxmlformats.org/drawingml/2006/main">
+          <a:bodyPr/>
+          <a:p/>
+        </p:txBody>
       </p:sp>
       <p:sp>
         <p:nvSpPr>
@@ -15768,6 +15792,10 @@
             <a:schemeClr val="tx1"/>
           </a:fontRef>
         </p:style>
+        <p:txBody xmlns:a="http://schemas.openxmlformats.org/drawingml/2006/main">
+          <a:bodyPr/>
+          <a:p/>
+        </p:txBody>
       </p:sp>
       <p:sp>
         <p:nvSpPr>
@@ -16094,7 +16122,7 @@
                 <a:ea typeface="Aptos"/>
                 <a:cs typeface="Aptos"/>
               </a:rPr>
-              <a:t>Note: the diagram represents the current prototype; target-account role assumption is not verified.</a:t>
+              <a:t>Invalid request IDs are rejected; target-account role assumption remains unverified.</a:t>
             </a:r>
           </a:p>
         </p:txBody>
@@ -20006,142 +20034,13 @@
                 <a:ea typeface="Aptos"/>
                 <a:cs typeface="Aptos"/>
               </a:rPr>
-              <a:t>1. A user publishes a JSON request to crossaccount/request.</a:t>
-            </a:r>
-          </a:p>
-          <a:p xmlns:a="http://schemas.openxmlformats.org/drawingml/2006/main">
-            <a:pPr algn="l">
-              <a:spcAft>
-                <a:spcPts val="1300"/>
-              </a:spcAft>
-              <a:buNone/>
-              <a:defRPr sz="1900">
-                <a:solidFill>
-                  <a:srgbClr val="2D3748"/>
-                </a:solidFill>
-                <a:latin typeface="Aptos"/>
-                <a:ea typeface="Aptos"/>
-                <a:cs typeface="Aptos"/>
-              </a:defRPr>
-            </a:pPr>
-            <a:r>
-              <a:rPr sz="1900">
-                <a:solidFill>
-                  <a:srgbClr val="2D3748"/>
-                </a:solidFill>
-                <a:latin typeface="Aptos"/>
-                <a:ea typeface="Aptos"/>
-                <a:cs typeface="Aptos"/>
-              </a:rPr>
-              <a:t>2. AWS IoT Core evaluates the message against the configured IoT rule.</a:t>
-            </a:r>
-          </a:p>
-          <a:p xmlns:a="http://schemas.openxmlformats.org/drawingml/2006/main">
-            <a:pPr algn="l">
-              <a:spcAft>
-                <a:spcPts val="1300"/>
-              </a:spcAft>
-              <a:buNone/>
-              <a:defRPr sz="1900">
-                <a:solidFill>
-                  <a:srgbClr val="2D3748"/>
-                </a:solidFill>
-                <a:latin typeface="Aptos"/>
-                <a:ea typeface="Aptos"/>
-                <a:cs typeface="Aptos"/>
-              </a:defRPr>
-            </a:pPr>
-            <a:r>
-              <a:rPr sz="1900">
-                <a:solidFill>
-                  <a:srgbClr val="2D3748"/>
-                </a:solidFill>
-                <a:latin typeface="Aptos"/>
-                <a:ea typeface="Aptos"/>
-                <a:cs typeface="Aptos"/>
-              </a:rPr>
-              <a:t>3. The rule invokes CrossAccountAccessLambda.</a:t>
-            </a:r>
-          </a:p>
-          <a:p xmlns:a="http://schemas.openxmlformats.org/drawingml/2006/main">
-            <a:pPr algn="l">
-              <a:spcAft>
-                <a:spcPts val="1300"/>
-              </a:spcAft>
-              <a:buNone/>
-              <a:defRPr sz="1900">
-                <a:solidFill>
-                  <a:srgbClr val="2D3748"/>
-                </a:solidFill>
-                <a:latin typeface="Aptos"/>
-                <a:ea typeface="Aptos"/>
-                <a:cs typeface="Aptos"/>
-              </a:defRPr>
-            </a:pPr>
-            <a:r>
-              <a:rPr sz="1900">
-                <a:solidFill>
-                  <a:srgbClr val="2D3748"/>
-                </a:solidFill>
-                <a:latin typeface="Aptos"/>
-                <a:ea typeface="Aptos"/>
-                <a:cs typeface="Aptos"/>
-              </a:rPr>
-              <a:t>4. Lambda processes the request, obtains caller identity via STS, and performs an S3 access check.</a:t>
-            </a:r>
-          </a:p>
-          <a:p xmlns:a="http://schemas.openxmlformats.org/drawingml/2006/main">
-            <a:pPr algn="l">
-              <a:spcAft>
-                <a:spcPts val="1300"/>
-              </a:spcAft>
-              <a:buNone/>
-              <a:defRPr sz="1900">
-                <a:solidFill>
-                  <a:srgbClr val="2D3748"/>
-                </a:solidFill>
-                <a:latin typeface="Aptos"/>
-                <a:ea typeface="Aptos"/>
-                <a:cs typeface="Aptos"/>
-              </a:defRPr>
-            </a:pPr>
-            <a:r>
-              <a:rPr sz="1900">
-                <a:solidFill>
-                  <a:srgbClr val="2D3748"/>
-                </a:solidFill>
-                <a:latin typeface="Aptos"/>
-                <a:ea typeface="Aptos"/>
-                <a:cs typeface="Aptos"/>
-              </a:rPr>
-              <a:t>5. Lambda stores a JSON result under access-results/ and publishes a response to crossaccount/response.</a:t>
-            </a:r>
-          </a:p>
-          <a:p xmlns:a="http://schemas.openxmlformats.org/drawingml/2006/main">
-            <a:pPr algn="l">
-              <a:spcAft>
-                <a:spcPts val="1300"/>
-              </a:spcAft>
-              <a:buNone/>
-              <a:defRPr sz="1900">
-                <a:solidFill>
-                  <a:srgbClr val="2D3748"/>
-                </a:solidFill>
-                <a:latin typeface="Aptos"/>
-                <a:ea typeface="Aptos"/>
-                <a:cs typeface="Aptos"/>
-              </a:defRPr>
-            </a:pPr>
-            <a:r>
-              <a:rPr sz="1900">
-                <a:solidFill>
-                  <a:srgbClr val="2D3748"/>
-                </a:solidFill>
-                <a:latin typeface="Aptos"/>
-                <a:ea typeface="Aptos"/>
-                <a:cs typeface="Aptos"/>
-              </a:rPr>
-              <a:t>6. The Streamlit dashboard reads stored JSON objects and presents request history and metrics.</a:t>
+              <a:t>1. A user publishes a JSON request to crossaccount/request.
+2. AWS IoT Core evaluates the message against the configured IoT rule.
+3. The rule invokes CrossAccountAccessLambda.
+4. Lambda validates requestId; invalid IDs are marked FAILURE and skip identity/S3 checks.
+5. Valid requests proceed to STS caller-identity lookup and an S3 access check.
+6. Lambda stores a JSON result under access-results/ and publishes to crossaccount/response.
+7. Streamlit reads stored JSON objects and presents request history, metrics, and details.</a:t>
             </a:r>
           </a:p>
         </p:txBody>
@@ -24707,7 +24606,7 @@
                 <a:ea typeface="Aptos"/>
                 <a:cs typeface="Aptos"/>
               </a:rPr>
-              <a:t>7 Passed</a:t>
+              <a:t>14 Passed</a:t>
             </a:r>
           </a:p>
         </p:txBody>
@@ -24872,7 +24771,7 @@
                 <a:ea typeface="Aptos"/>
                 <a:cs typeface="Aptos"/>
               </a:rPr>
-              <a:t>TC-01, TC-02, TC-03, TC-04, TC-07, TC-08, TC-09</a:t>
+              <a:t>Unconditionally passed tests</a:t>
             </a:r>
           </a:p>
         </p:txBody>
@@ -25147,7 +25046,7 @@
                 <a:ea typeface="Aptos"/>
                 <a:cs typeface="Aptos"/>
               </a:rPr>
-              <a:t>1 Inconclusive</a:t>
+              <a:t>1 Qualified — Retest</a:t>
             </a:r>
           </a:p>
         </p:txBody>
@@ -25312,7 +25211,7 @@
                 <a:ea typeface="Aptos"/>
                 <a:cs typeface="Aptos"/>
               </a:rPr>
-              <a:t>Malformed JSON rejection point not confirmed.</a:t>
+              <a:t>TC-04: standalone empty JSON {} needs retesting.</a:t>
             </a:r>
           </a:p>
         </p:txBody>
@@ -25587,7 +25486,7 @@
                 <a:ea typeface="Aptos"/>
                 <a:cs typeface="Aptos"/>
               </a:rPr>
-              <a:t>1 Not Executed</a:t>
+              <a:t>2 Unresolved</a:t>
             </a:r>
           </a:p>
         </p:txBody>
@@ -25752,7 +25651,7 @@
                 <a:ea typeface="Aptos"/>
                 <a:cs typeface="Aptos"/>
               </a:rPr>
-              <a:t>Actual S3 access-denied scenario not tested.</a:t>
+              <a:t>TC-05 inconclusive; TC-06 S3 denial not executed.</a:t>
             </a:r>
           </a:p>
         </p:txBody>
@@ -25917,7 +25816,7 @@
                 <a:ea typeface="Aptos"/>
                 <a:cs typeface="Aptos"/>
               </a:rPr>
-              <a:t>Final end-to-end validation</a:t>
+              <a:t>End-to-end validation</a:t>
             </a:r>
           </a:p>
         </p:txBody>
@@ -26082,7 +25981,7 @@
                 <a:ea typeface="Aptos"/>
                 <a:cs typeface="Aptos"/>
               </a:rPr>
-              <a:t>Request ID: FINAL-TEST-001</a:t>
+              <a:t>Verified flow: MQTT request → Lambda processing → S3 result → dashboard visibility.</a:t>
             </a:r>
             <a:br>
               <a:rPr sz="1500" b="0">
@@ -26094,17 +25993,6 @@
                 <a:cs typeface="Aptos"/>
               </a:rPr>
             </a:br>
-            <a:r>
-              <a:rPr sz="1500" b="0">
-                <a:solidFill>
-                  <a:srgbClr val="2D3748"/>
-                </a:solidFill>
-                <a:latin typeface="Aptos"/>
-                <a:ea typeface="Aptos"/>
-                <a:cs typeface="Aptos"/>
-              </a:rPr>
-              <a:t>Message: “Final end-to-end validation”</a:t>
-            </a:r>
           </a:p>
         </p:txBody>
       </p:sp>
@@ -26268,7 +26156,7 @@
                 <a:ea typeface="Aptos"/>
                 <a:cs typeface="Aptos"/>
               </a:rPr>
-              <a:t>The user confirmed that MQTT processing, S3 storage, and dashboard visibility worked for the final test.</a:t>
+              <a:t>The end-to-end request flow and dashboard visibility were confirmed working; full cross-account role assumption remains unverified.</a:t>
             </a:r>
           </a:p>
         </p:txBody>

</xml_diff>